<commit_message>
docs: change LibraryLoanSystem presentation file
</commit_message>
<xml_diff>
--- a/docs/LibraryLoanSystem_Sunum.pptx
+++ b/docs/LibraryLoanSystem_Sunum.pptx
@@ -2763,7 +2763,7 @@
                 <a:latin typeface="Segoe UI" pitchFamily="34" charset="0"/>
                 <a:cs typeface="Segoe UI" pitchFamily="34" charset="-120"/>
               </a:rPr>
-              <a:t>Bölüm: Teknik Bilimler Meslek Yüksekokulu</a:t>
+              <a:t>Bölüm: Bilgisayar Programcılığı</a:t>
             </a:r>
             <a:endParaRPr lang="en-US" sz="1200" dirty="0"/>
           </a:p>
@@ -5895,6 +5895,10 @@
           </a:bodyPr>
           <a:lstStyle/>
           <a:p>
+            <a:pPr marL="342900" indent="-342900">
+              <a:buFont typeface="Arial" panose="020B0604020202020204" pitchFamily="34" charset="0"/>
+              <a:buChar char="•"/>
+            </a:pPr>
             <a:r>
               <a:rPr lang="en-US" sz="2400" dirty="0">
                 <a:solidFill>
@@ -5904,11 +5908,51 @@
                 <a:ea typeface="Segoe UI" pitchFamily="34" charset="-122"/>
                 <a:cs typeface="Segoe UI" pitchFamily="34" charset="-120"/>
               </a:rPr>
-              <a:t>SQL Injection riskini azaltmak için tüm kritik sorgularda SqlParameter kullanılmış.</a:t>
-            </a:r>
+              <a:t>SQL Injection riskini azaltmak için tüm kritik sorgularda SqlParameter </a:t>
+            </a:r>
+            <a:r>
+              <a:rPr lang="en-US" sz="2400" dirty="0" err="1">
+                <a:solidFill>
+                  <a:srgbClr val="1F2937"/>
+                </a:solidFill>
+                <a:latin typeface="Segoe UI" pitchFamily="34" charset="0"/>
+                <a:ea typeface="Segoe UI" pitchFamily="34" charset="-122"/>
+                <a:cs typeface="Segoe UI" pitchFamily="34" charset="-120"/>
+              </a:rPr>
+              <a:t>kullanılmış</a:t>
+            </a:r>
+            <a:r>
+              <a:rPr lang="en-US" sz="2400" dirty="0">
+                <a:solidFill>
+                  <a:srgbClr val="1F2937"/>
+                </a:solidFill>
+                <a:latin typeface="Segoe UI" pitchFamily="34" charset="0"/>
+                <a:ea typeface="Segoe UI" pitchFamily="34" charset="-122"/>
+                <a:cs typeface="Segoe UI" pitchFamily="34" charset="-120"/>
+              </a:rPr>
+              <a:t>.</a:t>
+            </a:r>
+            <a:endParaRPr lang="tr-TR" sz="2400" dirty="0">
+              <a:solidFill>
+                <a:srgbClr val="1F2937"/>
+              </a:solidFill>
+              <a:latin typeface="Segoe UI" pitchFamily="34" charset="0"/>
+              <a:ea typeface="Segoe UI" pitchFamily="34" charset="-122"/>
+              <a:cs typeface="Segoe UI" pitchFamily="34" charset="-120"/>
+            </a:endParaRPr>
+          </a:p>
+          <a:p>
+            <a:pPr marL="342900" indent="-342900">
+              <a:buFont typeface="Arial" panose="020B0604020202020204" pitchFamily="34" charset="0"/>
+              <a:buChar char="•"/>
+            </a:pPr>
             <a:endParaRPr lang="en-US" sz="2400" dirty="0"/>
           </a:p>
           <a:p>
+            <a:pPr marL="342900" indent="-342900">
+              <a:buFont typeface="Arial" panose="020B0604020202020204" pitchFamily="34" charset="0"/>
+              <a:buChar char="•"/>
+            </a:pPr>
             <a:r>
               <a:rPr lang="en-US" sz="2400" dirty="0">
                 <a:solidFill>
@@ -5918,11 +5962,51 @@
                 <a:ea typeface="Segoe UI" pitchFamily="34" charset="-122"/>
                 <a:cs typeface="Segoe UI" pitchFamily="34" charset="-120"/>
               </a:rPr>
-              <a:t>Aktif ödünç ilişkisi olan kitap ve üye silinmiyor; veri tutarlılığı korunuyor.</a:t>
-            </a:r>
+              <a:t>Aktif ödünç ilişkisi olan kitap ve üye silinmiyor; veri tutarlılığı </a:t>
+            </a:r>
+            <a:r>
+              <a:rPr lang="en-US" sz="2400" dirty="0" err="1">
+                <a:solidFill>
+                  <a:srgbClr val="1F2937"/>
+                </a:solidFill>
+                <a:latin typeface="Segoe UI" pitchFamily="34" charset="0"/>
+                <a:ea typeface="Segoe UI" pitchFamily="34" charset="-122"/>
+                <a:cs typeface="Segoe UI" pitchFamily="34" charset="-120"/>
+              </a:rPr>
+              <a:t>korunuyor</a:t>
+            </a:r>
+            <a:r>
+              <a:rPr lang="en-US" sz="2400" dirty="0">
+                <a:solidFill>
+                  <a:srgbClr val="1F2937"/>
+                </a:solidFill>
+                <a:latin typeface="Segoe UI" pitchFamily="34" charset="0"/>
+                <a:ea typeface="Segoe UI" pitchFamily="34" charset="-122"/>
+                <a:cs typeface="Segoe UI" pitchFamily="34" charset="-120"/>
+              </a:rPr>
+              <a:t>.</a:t>
+            </a:r>
+            <a:endParaRPr lang="tr-TR" sz="2400" dirty="0">
+              <a:solidFill>
+                <a:srgbClr val="1F2937"/>
+              </a:solidFill>
+              <a:latin typeface="Segoe UI" pitchFamily="34" charset="0"/>
+              <a:ea typeface="Segoe UI" pitchFamily="34" charset="-122"/>
+              <a:cs typeface="Segoe UI" pitchFamily="34" charset="-120"/>
+            </a:endParaRPr>
+          </a:p>
+          <a:p>
+            <a:pPr marL="342900" indent="-342900">
+              <a:buFont typeface="Arial" panose="020B0604020202020204" pitchFamily="34" charset="0"/>
+              <a:buChar char="•"/>
+            </a:pPr>
             <a:endParaRPr lang="en-US" sz="2400" dirty="0"/>
           </a:p>
           <a:p>
+            <a:pPr marL="342900" indent="-342900">
+              <a:buFont typeface="Arial" panose="020B0604020202020204" pitchFamily="34" charset="0"/>
+              <a:buChar char="•"/>
+            </a:pPr>
             <a:r>
               <a:rPr lang="en-US" sz="2400" dirty="0">
                 <a:solidFill>
@@ -5934,9 +6018,27 @@
               </a:rPr>
               <a:t>Yazar/kategori silmede bağlı kitap kontrolü var.</a:t>
             </a:r>
+            <a:endParaRPr lang="tr-TR" sz="2400" dirty="0">
+              <a:solidFill>
+                <a:srgbClr val="1F2937"/>
+              </a:solidFill>
+              <a:latin typeface="Segoe UI" pitchFamily="34" charset="0"/>
+              <a:ea typeface="Segoe UI" pitchFamily="34" charset="-122"/>
+              <a:cs typeface="Segoe UI" pitchFamily="34" charset="-120"/>
+            </a:endParaRPr>
+          </a:p>
+          <a:p>
+            <a:pPr marL="342900" indent="-342900">
+              <a:buFont typeface="Arial" panose="020B0604020202020204" pitchFamily="34" charset="0"/>
+              <a:buChar char="•"/>
+            </a:pPr>
             <a:endParaRPr lang="en-US" sz="2400" dirty="0"/>
           </a:p>
           <a:p>
+            <a:pPr marL="342900" indent="-342900">
+              <a:buFont typeface="Arial" panose="020B0604020202020204" pitchFamily="34" charset="0"/>
+              <a:buChar char="•"/>
+            </a:pPr>
             <a:r>
               <a:rPr lang="en-US" sz="2400" dirty="0">
                 <a:solidFill>
@@ -6293,6 +6395,10 @@
           </a:bodyPr>
           <a:lstStyle/>
           <a:p>
+            <a:pPr marL="457200" indent="-457200">
+              <a:buFont typeface="+mj-lt"/>
+              <a:buAutoNum type="arabicPeriod"/>
+            </a:pPr>
             <a:r>
               <a:rPr lang="en-US" sz="2400" dirty="0">
                 <a:solidFill>
@@ -6302,11 +6408,70 @@
                 <a:ea typeface="Segoe UI" pitchFamily="34" charset="-122"/>
                 <a:cs typeface="Segoe UI" pitchFamily="34" charset="-120"/>
               </a:rPr>
-              <a:t>Güçlü: Proje küçük ve okunabilir; her modülün form dosyası ayrı.</a:t>
+              <a:t>Güçlü: </a:t>
+            </a:r>
+            <a:r>
+              <a:rPr lang="en-US" sz="2400" dirty="0" err="1">
+                <a:solidFill>
+                  <a:srgbClr val="1F2937"/>
+                </a:solidFill>
+                <a:latin typeface="Segoe UI" pitchFamily="34" charset="0"/>
+                <a:ea typeface="Segoe UI" pitchFamily="34" charset="-122"/>
+                <a:cs typeface="Segoe UI" pitchFamily="34" charset="-120"/>
+              </a:rPr>
+              <a:t>Proje</a:t>
+            </a:r>
+            <a:r>
+              <a:rPr lang="en-US" sz="2400" dirty="0">
+                <a:solidFill>
+                  <a:srgbClr val="1F2937"/>
+                </a:solidFill>
+                <a:latin typeface="Segoe UI" pitchFamily="34" charset="0"/>
+                <a:ea typeface="Segoe UI" pitchFamily="34" charset="-122"/>
+                <a:cs typeface="Segoe UI" pitchFamily="34" charset="-120"/>
+              </a:rPr>
+              <a:t> </a:t>
+            </a:r>
+            <a:r>
+              <a:rPr lang="tr-TR" sz="2400">
+                <a:solidFill>
+                  <a:srgbClr val="1F2937"/>
+                </a:solidFill>
+                <a:latin typeface="Segoe UI" pitchFamily="34" charset="0"/>
+                <a:ea typeface="Segoe UI" pitchFamily="34" charset="-122"/>
+                <a:cs typeface="Segoe UI" pitchFamily="34" charset="-120"/>
+              </a:rPr>
+              <a:t>anlaşılır</a:t>
+            </a:r>
+            <a:r>
+              <a:rPr lang="en-US" sz="2400">
+                <a:solidFill>
+                  <a:srgbClr val="1F2937"/>
+                </a:solidFill>
+                <a:latin typeface="Segoe UI" pitchFamily="34" charset="0"/>
+                <a:ea typeface="Segoe UI" pitchFamily="34" charset="-122"/>
+                <a:cs typeface="Segoe UI" pitchFamily="34" charset="-120"/>
+              </a:rPr>
+              <a:t> </a:t>
+            </a:r>
+            <a:r>
+              <a:rPr lang="en-US" sz="2400" dirty="0">
+                <a:solidFill>
+                  <a:srgbClr val="1F2937"/>
+                </a:solidFill>
+                <a:latin typeface="Segoe UI" pitchFamily="34" charset="0"/>
+                <a:ea typeface="Segoe UI" pitchFamily="34" charset="-122"/>
+                <a:cs typeface="Segoe UI" pitchFamily="34" charset="-120"/>
+              </a:rPr>
+              <a:t>ve okunabilir; her modülün form dosyası ayrı.</a:t>
             </a:r>
             <a:endParaRPr lang="en-US" sz="2400" dirty="0"/>
           </a:p>
           <a:p>
+            <a:pPr marL="457200" indent="-457200">
+              <a:buFont typeface="+mj-lt"/>
+              <a:buAutoNum type="arabicPeriod"/>
+            </a:pPr>
             <a:r>
               <a:rPr lang="en-US" sz="2400" dirty="0">
                 <a:solidFill>
@@ -6321,6 +6486,10 @@
             <a:endParaRPr lang="en-US" sz="2400" dirty="0"/>
           </a:p>
           <a:p>
+            <a:pPr marL="457200" indent="-457200">
+              <a:buFont typeface="+mj-lt"/>
+              <a:buAutoNum type="arabicPeriod"/>
+            </a:pPr>
             <a:r>
               <a:rPr lang="en-US" sz="2400" dirty="0">
                 <a:solidFill>
@@ -7505,6 +7674,10 @@
           </a:bodyPr>
           <a:lstStyle/>
           <a:p>
+            <a:pPr marL="342900" indent="-342900">
+              <a:buFont typeface="Arial" panose="020B0604020202020204" pitchFamily="34" charset="0"/>
+              <a:buChar char="•"/>
+            </a:pPr>
             <a:r>
               <a:rPr lang="en-US" sz="2400" dirty="0">
                 <a:solidFill>
@@ -7519,6 +7692,10 @@
             <a:endParaRPr lang="en-US" sz="2400" dirty="0"/>
           </a:p>
           <a:p>
+            <a:pPr marL="342900" indent="-342900">
+              <a:buFont typeface="Arial" panose="020B0604020202020204" pitchFamily="34" charset="0"/>
+              <a:buChar char="•"/>
+            </a:pPr>
             <a:r>
               <a:rPr lang="en-US" sz="2400" dirty="0">
                 <a:solidFill>
@@ -7533,6 +7710,10 @@
             <a:endParaRPr lang="en-US" sz="2400" dirty="0"/>
           </a:p>
           <a:p>
+            <a:pPr marL="342900" indent="-342900">
+              <a:buFont typeface="Arial" panose="020B0604020202020204" pitchFamily="34" charset="0"/>
+              <a:buChar char="•"/>
+            </a:pPr>
             <a:r>
               <a:rPr lang="en-US" sz="2400" dirty="0">
                 <a:solidFill>
@@ -7547,6 +7728,10 @@
             <a:endParaRPr lang="en-US" sz="2400" dirty="0"/>
           </a:p>
           <a:p>
+            <a:pPr marL="342900" indent="-342900">
+              <a:buFont typeface="Arial" panose="020B0604020202020204" pitchFamily="34" charset="0"/>
+              <a:buChar char="•"/>
+            </a:pPr>
             <a:r>
               <a:rPr lang="en-US" sz="2400" dirty="0">
                 <a:solidFill>
@@ -7787,10 +7972,14 @@
         </p:spPr>
         <p:txBody>
           <a:bodyPr wrap="square" lIns="1016" tIns="1016" rIns="1016" bIns="1016" rtlCol="0" anchor="t">
-            <a:normAutofit/>
+            <a:normAutofit lnSpcReduction="10000"/>
           </a:bodyPr>
           <a:lstStyle/>
           <a:p>
+            <a:pPr marL="342900" indent="-342900">
+              <a:buFont typeface="Arial" panose="020B0604020202020204" pitchFamily="34" charset="0"/>
+              <a:buChar char="•"/>
+            </a:pPr>
             <a:r>
               <a:rPr lang="en-US" sz="2400" dirty="0">
                 <a:solidFill>
@@ -7800,11 +7989,51 @@
                 <a:ea typeface="Segoe UI" pitchFamily="34" charset="-122"/>
                 <a:cs typeface="Segoe UI" pitchFamily="34" charset="-120"/>
               </a:rPr>
-              <a:t>Kütüphane içindeki kitap, üye, yazar, kategori, ödünç ve iade süreçlerini tek masaüstü uygulamasında toplar.</a:t>
-            </a:r>
+              <a:t>Kütüphane içindeki kitap, üye, yazar, kategori, ödünç ve iade süreçlerini tek masaüstü uygulamasında </a:t>
+            </a:r>
+            <a:r>
+              <a:rPr lang="en-US" sz="2400" dirty="0" err="1">
+                <a:solidFill>
+                  <a:srgbClr val="1F2937"/>
+                </a:solidFill>
+                <a:latin typeface="Segoe UI" pitchFamily="34" charset="0"/>
+                <a:ea typeface="Segoe UI" pitchFamily="34" charset="-122"/>
+                <a:cs typeface="Segoe UI" pitchFamily="34" charset="-120"/>
+              </a:rPr>
+              <a:t>toplar</a:t>
+            </a:r>
+            <a:r>
+              <a:rPr lang="en-US" sz="2400" dirty="0">
+                <a:solidFill>
+                  <a:srgbClr val="1F2937"/>
+                </a:solidFill>
+                <a:latin typeface="Segoe UI" pitchFamily="34" charset="0"/>
+                <a:ea typeface="Segoe UI" pitchFamily="34" charset="-122"/>
+                <a:cs typeface="Segoe UI" pitchFamily="34" charset="-120"/>
+              </a:rPr>
+              <a:t>.</a:t>
+            </a:r>
+            <a:endParaRPr lang="tr-TR" sz="2400" dirty="0">
+              <a:solidFill>
+                <a:srgbClr val="1F2937"/>
+              </a:solidFill>
+              <a:latin typeface="Segoe UI" pitchFamily="34" charset="0"/>
+              <a:ea typeface="Segoe UI" pitchFamily="34" charset="-122"/>
+              <a:cs typeface="Segoe UI" pitchFamily="34" charset="-120"/>
+            </a:endParaRPr>
+          </a:p>
+          <a:p>
+            <a:pPr marL="342900" indent="-342900">
+              <a:buFont typeface="Arial" panose="020B0604020202020204" pitchFamily="34" charset="0"/>
+              <a:buChar char="•"/>
+            </a:pPr>
             <a:endParaRPr lang="en-US" sz="2400" dirty="0"/>
           </a:p>
           <a:p>
+            <a:pPr marL="342900" indent="-342900">
+              <a:buFont typeface="Arial" panose="020B0604020202020204" pitchFamily="34" charset="0"/>
+              <a:buChar char="•"/>
+            </a:pPr>
             <a:r>
               <a:rPr lang="en-US" sz="2400" dirty="0">
                 <a:solidFill>
@@ -7814,11 +8043,51 @@
                 <a:ea typeface="Segoe UI" pitchFamily="34" charset="-122"/>
                 <a:cs typeface="Segoe UI" pitchFamily="34" charset="-120"/>
               </a:rPr>
-              <a:t>Görev odaklı ekranlar kullanır: her temel varlık veya işlem için ayrı form bulunur.</a:t>
-            </a:r>
+              <a:t>Görev odaklı ekranlar kullanır: her temel varlık veya işlem için ayrı form </a:t>
+            </a:r>
+            <a:r>
+              <a:rPr lang="en-US" sz="2400" dirty="0" err="1">
+                <a:solidFill>
+                  <a:srgbClr val="1F2937"/>
+                </a:solidFill>
+                <a:latin typeface="Segoe UI" pitchFamily="34" charset="0"/>
+                <a:ea typeface="Segoe UI" pitchFamily="34" charset="-122"/>
+                <a:cs typeface="Segoe UI" pitchFamily="34" charset="-120"/>
+              </a:rPr>
+              <a:t>bulunur</a:t>
+            </a:r>
+            <a:r>
+              <a:rPr lang="en-US" sz="2400" dirty="0">
+                <a:solidFill>
+                  <a:srgbClr val="1F2937"/>
+                </a:solidFill>
+                <a:latin typeface="Segoe UI" pitchFamily="34" charset="0"/>
+                <a:ea typeface="Segoe UI" pitchFamily="34" charset="-122"/>
+                <a:cs typeface="Segoe UI" pitchFamily="34" charset="-120"/>
+              </a:rPr>
+              <a:t>.</a:t>
+            </a:r>
+            <a:endParaRPr lang="tr-TR" sz="2400" dirty="0">
+              <a:solidFill>
+                <a:srgbClr val="1F2937"/>
+              </a:solidFill>
+              <a:latin typeface="Segoe UI" pitchFamily="34" charset="0"/>
+              <a:ea typeface="Segoe UI" pitchFamily="34" charset="-122"/>
+              <a:cs typeface="Segoe UI" pitchFamily="34" charset="-120"/>
+            </a:endParaRPr>
+          </a:p>
+          <a:p>
+            <a:pPr marL="342900" indent="-342900">
+              <a:buFont typeface="Arial" panose="020B0604020202020204" pitchFamily="34" charset="0"/>
+              <a:buChar char="•"/>
+            </a:pPr>
             <a:endParaRPr lang="en-US" sz="2400" dirty="0"/>
           </a:p>
           <a:p>
+            <a:pPr marL="342900" indent="-342900">
+              <a:buFont typeface="Arial" panose="020B0604020202020204" pitchFamily="34" charset="0"/>
+              <a:buChar char="•"/>
+            </a:pPr>
             <a:r>
               <a:rPr lang="en-US" sz="2400" dirty="0">
                 <a:solidFill>
@@ -7828,11 +8097,73 @@
                 <a:ea typeface="Segoe UI" pitchFamily="34" charset="-122"/>
                 <a:cs typeface="Segoe UI" pitchFamily="34" charset="-120"/>
               </a:rPr>
-              <a:t>Kullanıcı işlemleri doğrudan SQL Server veritabanına yazılır ve listeler anlık yenilenir.</a:t>
-            </a:r>
+              <a:t>Kullanıcı işlemleri doğrudan SQL Server veritabanına yazılır ve listeler anlık </a:t>
+            </a:r>
+            <a:r>
+              <a:rPr lang="en-US" sz="2400" dirty="0" err="1">
+                <a:solidFill>
+                  <a:srgbClr val="1F2937"/>
+                </a:solidFill>
+                <a:latin typeface="Segoe UI" pitchFamily="34" charset="0"/>
+                <a:ea typeface="Segoe UI" pitchFamily="34" charset="-122"/>
+                <a:cs typeface="Segoe UI" pitchFamily="34" charset="-120"/>
+              </a:rPr>
+              <a:t>yenilenir</a:t>
+            </a:r>
+            <a:r>
+              <a:rPr lang="en-US" sz="2400" dirty="0">
+                <a:solidFill>
+                  <a:srgbClr val="1F2937"/>
+                </a:solidFill>
+                <a:latin typeface="Segoe UI" pitchFamily="34" charset="0"/>
+                <a:ea typeface="Segoe UI" pitchFamily="34" charset="-122"/>
+                <a:cs typeface="Segoe UI" pitchFamily="34" charset="-120"/>
+              </a:rPr>
+              <a:t>.</a:t>
+            </a:r>
+            <a:endParaRPr lang="tr-TR" sz="2400" dirty="0">
+              <a:solidFill>
+                <a:srgbClr val="1F2937"/>
+              </a:solidFill>
+              <a:latin typeface="Segoe UI" pitchFamily="34" charset="0"/>
+              <a:ea typeface="Segoe UI" pitchFamily="34" charset="-122"/>
+              <a:cs typeface="Segoe UI" pitchFamily="34" charset="-120"/>
+            </a:endParaRPr>
+          </a:p>
+          <a:p>
+            <a:pPr marL="342900" indent="-342900">
+              <a:buFont typeface="Arial" panose="020B0604020202020204" pitchFamily="34" charset="0"/>
+              <a:buChar char="•"/>
+            </a:pPr>
             <a:endParaRPr lang="en-US" sz="2400" dirty="0"/>
           </a:p>
           <a:p>
+            <a:pPr marL="342900" indent="-342900">
+              <a:buFont typeface="Arial" panose="020B0604020202020204" pitchFamily="34" charset="0"/>
+              <a:buChar char="•"/>
+            </a:pPr>
+            <a:r>
+              <a:rPr lang="tr-TR" sz="2400" dirty="0">
+                <a:solidFill>
+                  <a:srgbClr val="1F2937"/>
+                </a:solidFill>
+                <a:latin typeface="Segoe UI" pitchFamily="34" charset="0"/>
+                <a:ea typeface="Segoe UI" pitchFamily="34" charset="-122"/>
+                <a:cs typeface="Segoe UI" pitchFamily="34" charset="-120"/>
+              </a:rPr>
+              <a:t>Yerel kütüphane ve Üniversite </a:t>
+            </a:r>
+            <a:r>
+              <a:rPr lang="en-US" sz="2400" dirty="0" err="1">
+                <a:solidFill>
+                  <a:srgbClr val="1F2937"/>
+                </a:solidFill>
+                <a:latin typeface="Segoe UI" pitchFamily="34" charset="0"/>
+                <a:ea typeface="Segoe UI" pitchFamily="34" charset="-122"/>
+                <a:cs typeface="Segoe UI" pitchFamily="34" charset="-120"/>
+              </a:rPr>
+              <a:t>kullanıcı</a:t>
+            </a:r>
             <a:r>
               <a:rPr lang="en-US" sz="2400" dirty="0">
                 <a:solidFill>
@@ -7842,11 +8173,51 @@
                 <a:ea typeface="Segoe UI" pitchFamily="34" charset="-122"/>
                 <a:cs typeface="Segoe UI" pitchFamily="34" charset="-120"/>
               </a:rPr>
-              <a:t>Eğitim projesi için anlaşılır, küçük ekip/tek kullanıcı senaryosuna uygun bir yapıdadır.</a:t>
-            </a:r>
+              <a:t> senaryosuna uygun bir </a:t>
+            </a:r>
+            <a:r>
+              <a:rPr lang="en-US" sz="2400" dirty="0" err="1">
+                <a:solidFill>
+                  <a:srgbClr val="1F2937"/>
+                </a:solidFill>
+                <a:latin typeface="Segoe UI" pitchFamily="34" charset="0"/>
+                <a:ea typeface="Segoe UI" pitchFamily="34" charset="-122"/>
+                <a:cs typeface="Segoe UI" pitchFamily="34" charset="-120"/>
+              </a:rPr>
+              <a:t>yapıdadır</a:t>
+            </a:r>
+            <a:r>
+              <a:rPr lang="en-US" sz="2400" dirty="0">
+                <a:solidFill>
+                  <a:srgbClr val="1F2937"/>
+                </a:solidFill>
+                <a:latin typeface="Segoe UI" pitchFamily="34" charset="0"/>
+                <a:ea typeface="Segoe UI" pitchFamily="34" charset="-122"/>
+                <a:cs typeface="Segoe UI" pitchFamily="34" charset="-120"/>
+              </a:rPr>
+              <a:t>.</a:t>
+            </a:r>
+            <a:endParaRPr lang="tr-TR" sz="2400" dirty="0">
+              <a:solidFill>
+                <a:srgbClr val="1F2937"/>
+              </a:solidFill>
+              <a:latin typeface="Segoe UI" pitchFamily="34" charset="0"/>
+              <a:ea typeface="Segoe UI" pitchFamily="34" charset="-122"/>
+              <a:cs typeface="Segoe UI" pitchFamily="34" charset="-120"/>
+            </a:endParaRPr>
+          </a:p>
+          <a:p>
+            <a:pPr marL="342900" indent="-342900">
+              <a:buFont typeface="Arial" panose="020B0604020202020204" pitchFamily="34" charset="0"/>
+              <a:buChar char="•"/>
+            </a:pPr>
             <a:endParaRPr lang="en-US" sz="2400" dirty="0"/>
           </a:p>
           <a:p>
+            <a:pPr marL="342900" indent="-342900">
+              <a:buFont typeface="Arial" panose="020B0604020202020204" pitchFamily="34" charset="0"/>
+              <a:buChar char="•"/>
+            </a:pPr>
             <a:r>
               <a:rPr lang="en-US" sz="2400" dirty="0">
                 <a:solidFill>
@@ -7856,7 +8227,29 @@
                 <a:ea typeface="Segoe UI" pitchFamily="34" charset="-122"/>
                 <a:cs typeface="Segoe UI" pitchFamily="34" charset="-120"/>
               </a:rPr>
-              <a:t>Ana mesaj: Basit WinForms arayüzüyle gerçek kütüphane operasyonlarını uçtan uca yönetir.</a:t>
+              <a:t>Ana mesaj: </a:t>
+            </a:r>
+            <a:r>
+              <a:rPr lang="tr-TR" sz="2400" dirty="0">
+                <a:solidFill>
+                  <a:srgbClr val="1F2937"/>
+                </a:solidFill>
+                <a:latin typeface="Segoe UI" pitchFamily="34" charset="0"/>
+                <a:ea typeface="Segoe UI" pitchFamily="34" charset="-122"/>
+                <a:cs typeface="Segoe UI" pitchFamily="34" charset="-120"/>
+              </a:rPr>
+              <a:t>Sade ve anlaşılır</a:t>
+            </a:r>
+            <a:r>
+              <a:rPr lang="en-US" sz="2400" dirty="0">
+                <a:solidFill>
+                  <a:srgbClr val="1F2937"/>
+                </a:solidFill>
+                <a:latin typeface="Segoe UI" pitchFamily="34" charset="0"/>
+                <a:ea typeface="Segoe UI" pitchFamily="34" charset="-122"/>
+                <a:cs typeface="Segoe UI" pitchFamily="34" charset="-120"/>
+              </a:rPr>
+              <a:t> WinForms arayüzüyle gerçek kütüphane operasyonlarını uçtan uca yönetir.</a:t>
             </a:r>
             <a:endParaRPr lang="en-US" sz="2400" dirty="0"/>
           </a:p>
@@ -8627,6 +9020,10 @@
           </a:bodyPr>
           <a:lstStyle/>
           <a:p>
+            <a:pPr marL="342900" indent="-342900">
+              <a:buFont typeface="Arial" panose="020B0604020202020204" pitchFamily="34" charset="0"/>
+              <a:buChar char="•"/>
+            </a:pPr>
             <a:r>
               <a:rPr lang="en-US" sz="2400" dirty="0">
                 <a:solidFill>
@@ -8636,11 +9033,51 @@
                 <a:ea typeface="Segoe UI" pitchFamily="34" charset="-122"/>
                 <a:cs typeface="Segoe UI" pitchFamily="34" charset="-120"/>
               </a:rPr>
-              <a:t>Program.cs: uygulama giriş noktası, MainForm ile başlatır.</a:t>
-            </a:r>
+              <a:t>Program.cs: uygulama giriş noktası, MainForm ile </a:t>
+            </a:r>
+            <a:r>
+              <a:rPr lang="en-US" sz="2400" dirty="0" err="1">
+                <a:solidFill>
+                  <a:srgbClr val="1F2937"/>
+                </a:solidFill>
+                <a:latin typeface="Segoe UI" pitchFamily="34" charset="0"/>
+                <a:ea typeface="Segoe UI" pitchFamily="34" charset="-122"/>
+                <a:cs typeface="Segoe UI" pitchFamily="34" charset="-120"/>
+              </a:rPr>
+              <a:t>başlatır</a:t>
+            </a:r>
+            <a:r>
+              <a:rPr lang="en-US" sz="2400" dirty="0">
+                <a:solidFill>
+                  <a:srgbClr val="1F2937"/>
+                </a:solidFill>
+                <a:latin typeface="Segoe UI" pitchFamily="34" charset="0"/>
+                <a:ea typeface="Segoe UI" pitchFamily="34" charset="-122"/>
+                <a:cs typeface="Segoe UI" pitchFamily="34" charset="-120"/>
+              </a:rPr>
+              <a:t>.</a:t>
+            </a:r>
+            <a:endParaRPr lang="tr-TR" sz="2400" dirty="0">
+              <a:solidFill>
+                <a:srgbClr val="1F2937"/>
+              </a:solidFill>
+              <a:latin typeface="Segoe UI" pitchFamily="34" charset="0"/>
+              <a:ea typeface="Segoe UI" pitchFamily="34" charset="-122"/>
+              <a:cs typeface="Segoe UI" pitchFamily="34" charset="-120"/>
+            </a:endParaRPr>
+          </a:p>
+          <a:p>
+            <a:pPr marL="342900" indent="-342900">
+              <a:buFont typeface="Arial" panose="020B0604020202020204" pitchFamily="34" charset="0"/>
+              <a:buChar char="•"/>
+            </a:pPr>
             <a:endParaRPr lang="en-US" sz="2400" dirty="0"/>
           </a:p>
           <a:p>
+            <a:pPr marL="342900" indent="-342900">
+              <a:buFont typeface="Arial" panose="020B0604020202020204" pitchFamily="34" charset="0"/>
+              <a:buChar char="•"/>
+            </a:pPr>
             <a:r>
               <a:rPr lang="en-US" sz="2400" dirty="0">
                 <a:solidFill>
@@ -8650,11 +9087,51 @@
                 <a:ea typeface="Segoe UI" pitchFamily="34" charset="-122"/>
                 <a:cs typeface="Segoe UI" pitchFamily="34" charset="-120"/>
               </a:rPr>
-              <a:t>Forms/: tüm ekranlar ve UI yardımcı sınıfları burada.</a:t>
-            </a:r>
+              <a:t>Forms/: tüm ekranlar ve UI yardımcı sınıfları </a:t>
+            </a:r>
+            <a:r>
+              <a:rPr lang="en-US" sz="2400" dirty="0" err="1">
+                <a:solidFill>
+                  <a:srgbClr val="1F2937"/>
+                </a:solidFill>
+                <a:latin typeface="Segoe UI" pitchFamily="34" charset="0"/>
+                <a:ea typeface="Segoe UI" pitchFamily="34" charset="-122"/>
+                <a:cs typeface="Segoe UI" pitchFamily="34" charset="-120"/>
+              </a:rPr>
+              <a:t>burada</a:t>
+            </a:r>
+            <a:r>
+              <a:rPr lang="en-US" sz="2400" dirty="0">
+                <a:solidFill>
+                  <a:srgbClr val="1F2937"/>
+                </a:solidFill>
+                <a:latin typeface="Segoe UI" pitchFamily="34" charset="0"/>
+                <a:ea typeface="Segoe UI" pitchFamily="34" charset="-122"/>
+                <a:cs typeface="Segoe UI" pitchFamily="34" charset="-120"/>
+              </a:rPr>
+              <a:t>.</a:t>
+            </a:r>
+            <a:endParaRPr lang="tr-TR" sz="2400" dirty="0">
+              <a:solidFill>
+                <a:srgbClr val="1F2937"/>
+              </a:solidFill>
+              <a:latin typeface="Segoe UI" pitchFamily="34" charset="0"/>
+              <a:ea typeface="Segoe UI" pitchFamily="34" charset="-122"/>
+              <a:cs typeface="Segoe UI" pitchFamily="34" charset="-120"/>
+            </a:endParaRPr>
+          </a:p>
+          <a:p>
+            <a:pPr marL="342900" indent="-342900">
+              <a:buFont typeface="Arial" panose="020B0604020202020204" pitchFamily="34" charset="0"/>
+              <a:buChar char="•"/>
+            </a:pPr>
             <a:endParaRPr lang="en-US" sz="2400" dirty="0"/>
           </a:p>
           <a:p>
+            <a:pPr marL="342900" indent="-342900">
+              <a:buFont typeface="Arial" panose="020B0604020202020204" pitchFamily="34" charset="0"/>
+              <a:buChar char="•"/>
+            </a:pPr>
             <a:r>
               <a:rPr lang="en-US" sz="2400" dirty="0">
                 <a:solidFill>
@@ -8664,11 +9141,51 @@
                 <a:ea typeface="Segoe UI" pitchFamily="34" charset="-122"/>
                 <a:cs typeface="Segoe UI" pitchFamily="34" charset="-120"/>
               </a:rPr>
-              <a:t>DataAccess/: Database bağlantı dizesi ve DbHelper SQL yardımcıları.</a:t>
-            </a:r>
+              <a:t>DataAccess/: Database bağlantı dizesi ve DbHelper SQL </a:t>
+            </a:r>
+            <a:r>
+              <a:rPr lang="en-US" sz="2400" dirty="0" err="1">
+                <a:solidFill>
+                  <a:srgbClr val="1F2937"/>
+                </a:solidFill>
+                <a:latin typeface="Segoe UI" pitchFamily="34" charset="0"/>
+                <a:ea typeface="Segoe UI" pitchFamily="34" charset="-122"/>
+                <a:cs typeface="Segoe UI" pitchFamily="34" charset="-120"/>
+              </a:rPr>
+              <a:t>yardımcıları</a:t>
+            </a:r>
+            <a:r>
+              <a:rPr lang="en-US" sz="2400" dirty="0">
+                <a:solidFill>
+                  <a:srgbClr val="1F2937"/>
+                </a:solidFill>
+                <a:latin typeface="Segoe UI" pitchFamily="34" charset="0"/>
+                <a:ea typeface="Segoe UI" pitchFamily="34" charset="-122"/>
+                <a:cs typeface="Segoe UI" pitchFamily="34" charset="-120"/>
+              </a:rPr>
+              <a:t>.</a:t>
+            </a:r>
+            <a:endParaRPr lang="tr-TR" sz="2400" dirty="0">
+              <a:solidFill>
+                <a:srgbClr val="1F2937"/>
+              </a:solidFill>
+              <a:latin typeface="Segoe UI" pitchFamily="34" charset="0"/>
+              <a:ea typeface="Segoe UI" pitchFamily="34" charset="-122"/>
+              <a:cs typeface="Segoe UI" pitchFamily="34" charset="-120"/>
+            </a:endParaRPr>
+          </a:p>
+          <a:p>
+            <a:pPr marL="342900" indent="-342900">
+              <a:buFont typeface="Arial" panose="020B0604020202020204" pitchFamily="34" charset="0"/>
+              <a:buChar char="•"/>
+            </a:pPr>
             <a:endParaRPr lang="en-US" sz="2400" dirty="0"/>
           </a:p>
           <a:p>
+            <a:pPr marL="342900" indent="-342900">
+              <a:buFont typeface="Arial" panose="020B0604020202020204" pitchFamily="34" charset="0"/>
+              <a:buChar char="•"/>
+            </a:pPr>
             <a:r>
               <a:rPr lang="en-US" sz="2400" dirty="0">
                 <a:solidFill>
@@ -8678,11 +9195,51 @@
                 <a:ea typeface="Segoe UI" pitchFamily="34" charset="-122"/>
                 <a:cs typeface="Segoe UI" pitchFamily="34" charset="-120"/>
               </a:rPr>
-              <a:t>Properties/: assembly, resources ve settings dosyaları.</a:t>
-            </a:r>
+              <a:t>Properties/: assembly, resources ve settings </a:t>
+            </a:r>
+            <a:r>
+              <a:rPr lang="en-US" sz="2400" dirty="0" err="1">
+                <a:solidFill>
+                  <a:srgbClr val="1F2937"/>
+                </a:solidFill>
+                <a:latin typeface="Segoe UI" pitchFamily="34" charset="0"/>
+                <a:ea typeface="Segoe UI" pitchFamily="34" charset="-122"/>
+                <a:cs typeface="Segoe UI" pitchFamily="34" charset="-120"/>
+              </a:rPr>
+              <a:t>dosyaları</a:t>
+            </a:r>
+            <a:r>
+              <a:rPr lang="en-US" sz="2400" dirty="0">
+                <a:solidFill>
+                  <a:srgbClr val="1F2937"/>
+                </a:solidFill>
+                <a:latin typeface="Segoe UI" pitchFamily="34" charset="0"/>
+                <a:ea typeface="Segoe UI" pitchFamily="34" charset="-122"/>
+                <a:cs typeface="Segoe UI" pitchFamily="34" charset="-120"/>
+              </a:rPr>
+              <a:t>.</a:t>
+            </a:r>
+            <a:endParaRPr lang="tr-TR" sz="2400" dirty="0">
+              <a:solidFill>
+                <a:srgbClr val="1F2937"/>
+              </a:solidFill>
+              <a:latin typeface="Segoe UI" pitchFamily="34" charset="0"/>
+              <a:ea typeface="Segoe UI" pitchFamily="34" charset="-122"/>
+              <a:cs typeface="Segoe UI" pitchFamily="34" charset="-120"/>
+            </a:endParaRPr>
+          </a:p>
+          <a:p>
+            <a:pPr marL="342900" indent="-342900">
+              <a:buFont typeface="Arial" panose="020B0604020202020204" pitchFamily="34" charset="0"/>
+              <a:buChar char="•"/>
+            </a:pPr>
             <a:endParaRPr lang="en-US" sz="2400" dirty="0"/>
           </a:p>
           <a:p>
+            <a:pPr marL="342900" indent="-342900">
+              <a:buFont typeface="Arial" panose="020B0604020202020204" pitchFamily="34" charset="0"/>
+              <a:buChar char="•"/>
+            </a:pPr>
             <a:r>
               <a:rPr lang="en-US" sz="2400" dirty="0">
                 <a:solidFill>
@@ -8692,7 +9249,18 @@
                 <a:ea typeface="Segoe UI" pitchFamily="34" charset="-122"/>
                 <a:cs typeface="Segoe UI" pitchFamily="34" charset="-120"/>
               </a:rPr>
-              <a:t>images/marun_logo.png: ana ekranda kullanılmak üzere projeye content olarak </a:t>
+              <a:t>images/marun_logo.png: </a:t>
+            </a:r>
+            <a:r>
+              <a:rPr lang="tr-TR" sz="2400" dirty="0">
+                <a:solidFill>
+                  <a:srgbClr val="1F2937"/>
+                </a:solidFill>
+                <a:latin typeface="Segoe UI" pitchFamily="34" charset="0"/>
+                <a:ea typeface="Segoe UI" pitchFamily="34" charset="-122"/>
+                <a:cs typeface="Segoe UI" pitchFamily="34" charset="-120"/>
+              </a:rPr>
+              <a:t>A</a:t>
             </a:r>
             <a:r>
               <a:rPr lang="en-US" sz="2400" dirty="0" err="1">
@@ -8703,6 +9271,28 @@
                 <a:ea typeface="Segoe UI" pitchFamily="34" charset="-122"/>
                 <a:cs typeface="Segoe UI" pitchFamily="34" charset="-120"/>
               </a:rPr>
+              <a:t>na</a:t>
+            </a:r>
+            <a:r>
+              <a:rPr lang="en-US" sz="2400" dirty="0">
+                <a:solidFill>
+                  <a:srgbClr val="1F2937"/>
+                </a:solidFill>
+                <a:latin typeface="Segoe UI" pitchFamily="34" charset="0"/>
+                <a:ea typeface="Segoe UI" pitchFamily="34" charset="-122"/>
+                <a:cs typeface="Segoe UI" pitchFamily="34" charset="-120"/>
+              </a:rPr>
+              <a:t> ekranda kullanılmak üzere projeye content olarak </a:t>
+            </a:r>
+            <a:r>
+              <a:rPr lang="en-US" sz="2400" dirty="0" err="1">
+                <a:solidFill>
+                  <a:srgbClr val="1F2937"/>
+                </a:solidFill>
+                <a:latin typeface="Segoe UI" pitchFamily="34" charset="0"/>
+                <a:ea typeface="Segoe UI" pitchFamily="34" charset="-122"/>
+                <a:cs typeface="Segoe UI" pitchFamily="34" charset="-120"/>
+              </a:rPr>
               <a:t>eklenmiş</a:t>
             </a:r>
             <a:r>
@@ -8717,7 +9307,7 @@
               <a:t> logo</a:t>
             </a:r>
             <a:r>
-              <a:rPr lang="tr-TR" sz="2400">
+              <a:rPr lang="tr-TR" sz="2400" dirty="0">
                 <a:solidFill>
                   <a:srgbClr val="1F2937"/>
                 </a:solidFill>
@@ -10997,6 +11587,10 @@
           </a:bodyPr>
           <a:lstStyle/>
           <a:p>
+            <a:pPr marL="342900" indent="-342900">
+              <a:buFont typeface="Arial" panose="020B0604020202020204" pitchFamily="34" charset="0"/>
+              <a:buChar char="•"/>
+            </a:pPr>
             <a:r>
               <a:rPr lang="en-US" sz="2400" dirty="0">
                 <a:solidFill>
@@ -11006,11 +11600,51 @@
                 <a:ea typeface="Segoe UI" pitchFamily="34" charset="-122"/>
                 <a:cs typeface="Segoe UI" pitchFamily="34" charset="-120"/>
               </a:rPr>
-              <a:t>Program.Main içinde EnableVisualStyles çalışır ve uygulama MainForm ile açılır.</a:t>
-            </a:r>
+              <a:t>Program.Main içinde EnableVisualStyles çalışır ve uygulama MainForm ile </a:t>
+            </a:r>
+            <a:r>
+              <a:rPr lang="en-US" sz="2400" dirty="0" err="1">
+                <a:solidFill>
+                  <a:srgbClr val="1F2937"/>
+                </a:solidFill>
+                <a:latin typeface="Segoe UI" pitchFamily="34" charset="0"/>
+                <a:ea typeface="Segoe UI" pitchFamily="34" charset="-122"/>
+                <a:cs typeface="Segoe UI" pitchFamily="34" charset="-120"/>
+              </a:rPr>
+              <a:t>açılır</a:t>
+            </a:r>
+            <a:r>
+              <a:rPr lang="en-US" sz="2400" dirty="0">
+                <a:solidFill>
+                  <a:srgbClr val="1F2937"/>
+                </a:solidFill>
+                <a:latin typeface="Segoe UI" pitchFamily="34" charset="0"/>
+                <a:ea typeface="Segoe UI" pitchFamily="34" charset="-122"/>
+                <a:cs typeface="Segoe UI" pitchFamily="34" charset="-120"/>
+              </a:rPr>
+              <a:t>.</a:t>
+            </a:r>
+            <a:endParaRPr lang="tr-TR" sz="2400" dirty="0">
+              <a:solidFill>
+                <a:srgbClr val="1F2937"/>
+              </a:solidFill>
+              <a:latin typeface="Segoe UI" pitchFamily="34" charset="0"/>
+              <a:ea typeface="Segoe UI" pitchFamily="34" charset="-122"/>
+              <a:cs typeface="Segoe UI" pitchFamily="34" charset="-120"/>
+            </a:endParaRPr>
+          </a:p>
+          <a:p>
+            <a:pPr marL="342900" indent="-342900">
+              <a:buFont typeface="Arial" panose="020B0604020202020204" pitchFamily="34" charset="0"/>
+              <a:buChar char="•"/>
+            </a:pPr>
             <a:endParaRPr lang="en-US" sz="2400" dirty="0"/>
           </a:p>
           <a:p>
+            <a:pPr marL="342900" indent="-342900">
+              <a:buFont typeface="Arial" panose="020B0604020202020204" pitchFamily="34" charset="0"/>
+              <a:buChar char="•"/>
+            </a:pPr>
             <a:r>
               <a:rPr lang="en-US" sz="2400" dirty="0">
                 <a:solidFill>
@@ -11020,11 +11654,51 @@
                 <a:ea typeface="Segoe UI" pitchFamily="34" charset="-122"/>
                 <a:cs typeface="Segoe UI" pitchFamily="34" charset="-120"/>
               </a:rPr>
-              <a:t>MainForm, logo yükleme ve ana modül butonlarını yönetir.</a:t>
-            </a:r>
+              <a:t>MainForm, logo yükleme ve ana modül butonlarını </a:t>
+            </a:r>
+            <a:r>
+              <a:rPr lang="en-US" sz="2400" dirty="0" err="1">
+                <a:solidFill>
+                  <a:srgbClr val="1F2937"/>
+                </a:solidFill>
+                <a:latin typeface="Segoe UI" pitchFamily="34" charset="0"/>
+                <a:ea typeface="Segoe UI" pitchFamily="34" charset="-122"/>
+                <a:cs typeface="Segoe UI" pitchFamily="34" charset="-120"/>
+              </a:rPr>
+              <a:t>yönetir</a:t>
+            </a:r>
+            <a:r>
+              <a:rPr lang="en-US" sz="2400" dirty="0">
+                <a:solidFill>
+                  <a:srgbClr val="1F2937"/>
+                </a:solidFill>
+                <a:latin typeface="Segoe UI" pitchFamily="34" charset="0"/>
+                <a:ea typeface="Segoe UI" pitchFamily="34" charset="-122"/>
+                <a:cs typeface="Segoe UI" pitchFamily="34" charset="-120"/>
+              </a:rPr>
+              <a:t>.</a:t>
+            </a:r>
+            <a:endParaRPr lang="tr-TR" sz="2400" dirty="0">
+              <a:solidFill>
+                <a:srgbClr val="1F2937"/>
+              </a:solidFill>
+              <a:latin typeface="Segoe UI" pitchFamily="34" charset="0"/>
+              <a:ea typeface="Segoe UI" pitchFamily="34" charset="-122"/>
+              <a:cs typeface="Segoe UI" pitchFamily="34" charset="-120"/>
+            </a:endParaRPr>
+          </a:p>
+          <a:p>
+            <a:pPr marL="342900" indent="-342900">
+              <a:buFont typeface="Arial" panose="020B0604020202020204" pitchFamily="34" charset="0"/>
+              <a:buChar char="•"/>
+            </a:pPr>
             <a:endParaRPr lang="en-US" sz="2400" dirty="0"/>
           </a:p>
           <a:p>
+            <a:pPr marL="342900" indent="-342900">
+              <a:buFont typeface="Arial" panose="020B0604020202020204" pitchFamily="34" charset="0"/>
+              <a:buChar char="•"/>
+            </a:pPr>
             <a:r>
               <a:rPr lang="en-US" sz="2400" dirty="0">
                 <a:solidFill>
@@ -11034,11 +11708,51 @@
                 <a:ea typeface="Segoe UI" pitchFamily="34" charset="-122"/>
                 <a:cs typeface="Segoe UI" pitchFamily="34" charset="-120"/>
               </a:rPr>
-              <a:t>Her buton ilgili formu ShowDialog ile modal olarak açar.</a:t>
-            </a:r>
+              <a:t>Her buton ilgili formu ShowDialog ile modal olarak </a:t>
+            </a:r>
+            <a:r>
+              <a:rPr lang="en-US" sz="2400" dirty="0" err="1">
+                <a:solidFill>
+                  <a:srgbClr val="1F2937"/>
+                </a:solidFill>
+                <a:latin typeface="Segoe UI" pitchFamily="34" charset="0"/>
+                <a:ea typeface="Segoe UI" pitchFamily="34" charset="-122"/>
+                <a:cs typeface="Segoe UI" pitchFamily="34" charset="-120"/>
+              </a:rPr>
+              <a:t>açar</a:t>
+            </a:r>
+            <a:r>
+              <a:rPr lang="en-US" sz="2400" dirty="0">
+                <a:solidFill>
+                  <a:srgbClr val="1F2937"/>
+                </a:solidFill>
+                <a:latin typeface="Segoe UI" pitchFamily="34" charset="0"/>
+                <a:ea typeface="Segoe UI" pitchFamily="34" charset="-122"/>
+                <a:cs typeface="Segoe UI" pitchFamily="34" charset="-120"/>
+              </a:rPr>
+              <a:t>.</a:t>
+            </a:r>
+            <a:endParaRPr lang="tr-TR" sz="2400" dirty="0">
+              <a:solidFill>
+                <a:srgbClr val="1F2937"/>
+              </a:solidFill>
+              <a:latin typeface="Segoe UI" pitchFamily="34" charset="0"/>
+              <a:ea typeface="Segoe UI" pitchFamily="34" charset="-122"/>
+              <a:cs typeface="Segoe UI" pitchFamily="34" charset="-120"/>
+            </a:endParaRPr>
+          </a:p>
+          <a:p>
+            <a:pPr marL="342900" indent="-342900">
+              <a:buFont typeface="Arial" panose="020B0604020202020204" pitchFamily="34" charset="0"/>
+              <a:buChar char="•"/>
+            </a:pPr>
             <a:endParaRPr lang="en-US" sz="2400" dirty="0"/>
           </a:p>
           <a:p>
+            <a:pPr marL="342900" indent="-342900">
+              <a:buFont typeface="Arial" panose="020B0604020202020204" pitchFamily="34" charset="0"/>
+              <a:buChar char="•"/>
+            </a:pPr>
             <a:r>
               <a:rPr lang="en-US" sz="2400" dirty="0">
                 <a:solidFill>
@@ -11050,9 +11764,27 @@
               </a:rPr>
               <a:t>Açılan modüller: Kitaplar, Üyeler, Yazarlar, Kategoriler, Ödünç Ver, Aktif Ödünçler, Teslim Al.</a:t>
             </a:r>
+            <a:endParaRPr lang="tr-TR" sz="2400" dirty="0">
+              <a:solidFill>
+                <a:srgbClr val="1F2937"/>
+              </a:solidFill>
+              <a:latin typeface="Segoe UI" pitchFamily="34" charset="0"/>
+              <a:ea typeface="Segoe UI" pitchFamily="34" charset="-122"/>
+              <a:cs typeface="Segoe UI" pitchFamily="34" charset="-120"/>
+            </a:endParaRPr>
+          </a:p>
+          <a:p>
+            <a:pPr marL="342900" indent="-342900">
+              <a:buFont typeface="Arial" panose="020B0604020202020204" pitchFamily="34" charset="0"/>
+              <a:buChar char="•"/>
+            </a:pPr>
             <a:endParaRPr lang="en-US" sz="2400" dirty="0"/>
           </a:p>
           <a:p>
+            <a:pPr marL="342900" indent="-342900">
+              <a:buFont typeface="Arial" panose="020B0604020202020204" pitchFamily="34" charset="0"/>
+              <a:buChar char="•"/>
+            </a:pPr>
             <a:r>
               <a:rPr lang="en-US" sz="2400" dirty="0">
                 <a:solidFill>
@@ -11901,6 +12633,10 @@
           </a:bodyPr>
           <a:lstStyle/>
           <a:p>
+            <a:pPr marL="342900" indent="-342900">
+              <a:buFont typeface="Arial" panose="020B0604020202020204" pitchFamily="34" charset="0"/>
+              <a:buChar char="•"/>
+            </a:pPr>
             <a:r>
               <a:rPr lang="en-US" sz="2400" dirty="0">
                 <a:solidFill>
@@ -11910,11 +12646,51 @@
                 <a:ea typeface="Segoe UI" pitchFamily="34" charset="-122"/>
                 <a:cs typeface="Segoe UI" pitchFamily="34" charset="-120"/>
               </a:rPr>
-              <a:t>MembersForm; MemberId, FullName ve Phone alanlarını yönetir.</a:t>
-            </a:r>
+              <a:t>MembersForm; MemberId, FullName ve Phone alanlarını </a:t>
+            </a:r>
+            <a:r>
+              <a:rPr lang="en-US" sz="2400" dirty="0" err="1">
+                <a:solidFill>
+                  <a:srgbClr val="1F2937"/>
+                </a:solidFill>
+                <a:latin typeface="Segoe UI" pitchFamily="34" charset="0"/>
+                <a:ea typeface="Segoe UI" pitchFamily="34" charset="-122"/>
+                <a:cs typeface="Segoe UI" pitchFamily="34" charset="-120"/>
+              </a:rPr>
+              <a:t>yönetir</a:t>
+            </a:r>
+            <a:r>
+              <a:rPr lang="en-US" sz="2400" dirty="0">
+                <a:solidFill>
+                  <a:srgbClr val="1F2937"/>
+                </a:solidFill>
+                <a:latin typeface="Segoe UI" pitchFamily="34" charset="0"/>
+                <a:ea typeface="Segoe UI" pitchFamily="34" charset="-122"/>
+                <a:cs typeface="Segoe UI" pitchFamily="34" charset="-120"/>
+              </a:rPr>
+              <a:t>.</a:t>
+            </a:r>
+            <a:endParaRPr lang="tr-TR" sz="2400" dirty="0">
+              <a:solidFill>
+                <a:srgbClr val="1F2937"/>
+              </a:solidFill>
+              <a:latin typeface="Segoe UI" pitchFamily="34" charset="0"/>
+              <a:ea typeface="Segoe UI" pitchFamily="34" charset="-122"/>
+              <a:cs typeface="Segoe UI" pitchFamily="34" charset="-120"/>
+            </a:endParaRPr>
+          </a:p>
+          <a:p>
+            <a:pPr marL="342900" indent="-342900">
+              <a:buFont typeface="Arial" panose="020B0604020202020204" pitchFamily="34" charset="0"/>
+              <a:buChar char="•"/>
+            </a:pPr>
             <a:endParaRPr lang="en-US" sz="2400" dirty="0"/>
           </a:p>
           <a:p>
+            <a:pPr marL="342900" indent="-342900">
+              <a:buFont typeface="Arial" panose="020B0604020202020204" pitchFamily="34" charset="0"/>
+              <a:buChar char="•"/>
+            </a:pPr>
             <a:r>
               <a:rPr lang="en-US" sz="2400" dirty="0">
                 <a:solidFill>
@@ -11924,11 +12700,51 @@
                 <a:ea typeface="Segoe UI" pitchFamily="34" charset="-122"/>
                 <a:cs typeface="Segoe UI" pitchFamily="34" charset="-120"/>
               </a:rPr>
-              <a:t>FullName zorunlu, Phone isteğe bağlı ama format kontrolünden geçmeli.</a:t>
-            </a:r>
+              <a:t>FullName zorunlu, Phone isteğe bağlı ama format kontrolünden </a:t>
+            </a:r>
+            <a:r>
+              <a:rPr lang="en-US" sz="2400" dirty="0" err="1">
+                <a:solidFill>
+                  <a:srgbClr val="1F2937"/>
+                </a:solidFill>
+                <a:latin typeface="Segoe UI" pitchFamily="34" charset="0"/>
+                <a:ea typeface="Segoe UI" pitchFamily="34" charset="-122"/>
+                <a:cs typeface="Segoe UI" pitchFamily="34" charset="-120"/>
+              </a:rPr>
+              <a:t>geçmeli</a:t>
+            </a:r>
+            <a:r>
+              <a:rPr lang="en-US" sz="2400" dirty="0">
+                <a:solidFill>
+                  <a:srgbClr val="1F2937"/>
+                </a:solidFill>
+                <a:latin typeface="Segoe UI" pitchFamily="34" charset="0"/>
+                <a:ea typeface="Segoe UI" pitchFamily="34" charset="-122"/>
+                <a:cs typeface="Segoe UI" pitchFamily="34" charset="-120"/>
+              </a:rPr>
+              <a:t>.</a:t>
+            </a:r>
+            <a:endParaRPr lang="tr-TR" sz="2400" dirty="0">
+              <a:solidFill>
+                <a:srgbClr val="1F2937"/>
+              </a:solidFill>
+              <a:latin typeface="Segoe UI" pitchFamily="34" charset="0"/>
+              <a:ea typeface="Segoe UI" pitchFamily="34" charset="-122"/>
+              <a:cs typeface="Segoe UI" pitchFamily="34" charset="-120"/>
+            </a:endParaRPr>
+          </a:p>
+          <a:p>
+            <a:pPr marL="342900" indent="-342900">
+              <a:buFont typeface="Arial" panose="020B0604020202020204" pitchFamily="34" charset="0"/>
+              <a:buChar char="•"/>
+            </a:pPr>
             <a:endParaRPr lang="en-US" sz="2400" dirty="0"/>
           </a:p>
           <a:p>
+            <a:pPr marL="342900" indent="-342900">
+              <a:buFont typeface="Arial" panose="020B0604020202020204" pitchFamily="34" charset="0"/>
+              <a:buChar char="•"/>
+            </a:pPr>
             <a:r>
               <a:rPr lang="en-US" sz="2400" dirty="0">
                 <a:solidFill>
@@ -11938,11 +12754,51 @@
                 <a:ea typeface="Segoe UI" pitchFamily="34" charset="-122"/>
                 <a:cs typeface="Segoe UI" pitchFamily="34" charset="-120"/>
               </a:rPr>
-              <a:t>Telefon alanı için tekrar kontrolü var: aynı telefon farklı üyede kullanılamaz.</a:t>
-            </a:r>
+              <a:t>Telefon alanı için tekrar kontrolü var: aynı telefon farklı üyede </a:t>
+            </a:r>
+            <a:r>
+              <a:rPr lang="en-US" sz="2400" dirty="0" err="1">
+                <a:solidFill>
+                  <a:srgbClr val="1F2937"/>
+                </a:solidFill>
+                <a:latin typeface="Segoe UI" pitchFamily="34" charset="0"/>
+                <a:ea typeface="Segoe UI" pitchFamily="34" charset="-122"/>
+                <a:cs typeface="Segoe UI" pitchFamily="34" charset="-120"/>
+              </a:rPr>
+              <a:t>kullanılamaz</a:t>
+            </a:r>
+            <a:r>
+              <a:rPr lang="en-US" sz="2400" dirty="0">
+                <a:solidFill>
+                  <a:srgbClr val="1F2937"/>
+                </a:solidFill>
+                <a:latin typeface="Segoe UI" pitchFamily="34" charset="0"/>
+                <a:ea typeface="Segoe UI" pitchFamily="34" charset="-122"/>
+                <a:cs typeface="Segoe UI" pitchFamily="34" charset="-120"/>
+              </a:rPr>
+              <a:t>.</a:t>
+            </a:r>
+            <a:endParaRPr lang="tr-TR" sz="2400" dirty="0">
+              <a:solidFill>
+                <a:srgbClr val="1F2937"/>
+              </a:solidFill>
+              <a:latin typeface="Segoe UI" pitchFamily="34" charset="0"/>
+              <a:ea typeface="Segoe UI" pitchFamily="34" charset="-122"/>
+              <a:cs typeface="Segoe UI" pitchFamily="34" charset="-120"/>
+            </a:endParaRPr>
+          </a:p>
+          <a:p>
+            <a:pPr marL="342900" indent="-342900">
+              <a:buFont typeface="Arial" panose="020B0604020202020204" pitchFamily="34" charset="0"/>
+              <a:buChar char="•"/>
+            </a:pPr>
             <a:endParaRPr lang="en-US" sz="2400" dirty="0"/>
           </a:p>
           <a:p>
+            <a:pPr marL="342900" indent="-342900">
+              <a:buFont typeface="Arial" panose="020B0604020202020204" pitchFamily="34" charset="0"/>
+              <a:buChar char="•"/>
+            </a:pPr>
             <a:r>
               <a:rPr lang="en-US" sz="2400" dirty="0">
                 <a:solidFill>
@@ -11952,11 +12808,51 @@
                 <a:ea typeface="Segoe UI" pitchFamily="34" charset="-122"/>
                 <a:cs typeface="Segoe UI" pitchFamily="34" charset="-120"/>
               </a:rPr>
-              <a:t>Satır seçildiğinde Ekle pasif, Güncelle/Sil aktif hale getirilir; yanlışlıkla kopya ekleme riski azaltılır.</a:t>
-            </a:r>
+              <a:t>Satır seçildiğinde Ekle pasif, Güncelle/Sil aktif hale getirilir; yanlışlıkla kopya ekleme riski </a:t>
+            </a:r>
+            <a:r>
+              <a:rPr lang="en-US" sz="2400" dirty="0" err="1">
+                <a:solidFill>
+                  <a:srgbClr val="1F2937"/>
+                </a:solidFill>
+                <a:latin typeface="Segoe UI" pitchFamily="34" charset="0"/>
+                <a:ea typeface="Segoe UI" pitchFamily="34" charset="-122"/>
+                <a:cs typeface="Segoe UI" pitchFamily="34" charset="-120"/>
+              </a:rPr>
+              <a:t>azaltılır</a:t>
+            </a:r>
+            <a:r>
+              <a:rPr lang="en-US" sz="2400" dirty="0">
+                <a:solidFill>
+                  <a:srgbClr val="1F2937"/>
+                </a:solidFill>
+                <a:latin typeface="Segoe UI" pitchFamily="34" charset="0"/>
+                <a:ea typeface="Segoe UI" pitchFamily="34" charset="-122"/>
+                <a:cs typeface="Segoe UI" pitchFamily="34" charset="-120"/>
+              </a:rPr>
+              <a:t>.</a:t>
+            </a:r>
+            <a:endParaRPr lang="tr-TR" sz="2400" dirty="0">
+              <a:solidFill>
+                <a:srgbClr val="1F2937"/>
+              </a:solidFill>
+              <a:latin typeface="Segoe UI" pitchFamily="34" charset="0"/>
+              <a:ea typeface="Segoe UI" pitchFamily="34" charset="-122"/>
+              <a:cs typeface="Segoe UI" pitchFamily="34" charset="-120"/>
+            </a:endParaRPr>
+          </a:p>
+          <a:p>
+            <a:pPr marL="342900" indent="-342900">
+              <a:buFont typeface="Arial" panose="020B0604020202020204" pitchFamily="34" charset="0"/>
+              <a:buChar char="•"/>
+            </a:pPr>
             <a:endParaRPr lang="en-US" sz="2400" dirty="0"/>
           </a:p>
           <a:p>
+            <a:pPr marL="342900" indent="-342900">
+              <a:buFont typeface="Arial" panose="020B0604020202020204" pitchFamily="34" charset="0"/>
+              <a:buChar char="•"/>
+            </a:pPr>
             <a:r>
               <a:rPr lang="en-US" sz="2400" dirty="0">
                 <a:solidFill>

</xml_diff>